<commit_message>
Add slide transitions and slideshow auto-open mode
Post-processes the PPTX via JSZip to inject OOXML <p:transition> elements:
- Slide 1 & 10: slow cinematic fade-through-black
- Slides 2 & 8: push up
- Slides 3 & 4: wipe right
- Slides 5 & 9: smooth fade
- Slide 6: push left
- Slide 7: zoom out (dramatic reveal)

Also sets viewProps.xml lastView="sldShow" so the file opens directly
in Slideshow mode when double-clicked in PowerPoint/LibreOffice.

https://claude.ai/code/session_019hy8XUyexLdnWAtFPKPr5S
</commit_message>
<xml_diff>
--- a/NBA_Presentation_4K.pptx
+++ b/NBA_Presentation_4K.pptx
@@ -2800,6 +2800,9 @@
   <p:clrMapOvr>
     <a:masterClrMapping/>
   </p:clrMapOvr>
+  <p:transition spd="slow">
+    <p:fade thruBlk="1"/>
+  </p:transition>
 </p:sld>
 </file>
 
@@ -3224,6 +3227,9 @@
   <p:clrMapOvr>
     <a:masterClrMapping/>
   </p:clrMapOvr>
+  <p:transition spd="slow">
+    <p:fade thruBlk="1"/>
+  </p:transition>
 </p:sld>
 </file>
 
@@ -3920,6 +3926,9 @@
   <p:clrMapOvr>
     <a:masterClrMapping/>
   </p:clrMapOvr>
+  <p:transition spd="med">
+    <p:push dir="u"/>
+  </p:transition>
 </p:sld>
 </file>
 
@@ -6615,6 +6624,9 @@
   <p:clrMapOvr>
     <a:masterClrMapping/>
   </p:clrMapOvr>
+  <p:transition spd="med">
+    <p:wipe dir="r"/>
+  </p:transition>
 </p:sld>
 </file>
 
@@ -9310,6 +9322,9 @@
   <p:clrMapOvr>
     <a:masterClrMapping/>
   </p:clrMapOvr>
+  <p:transition spd="med">
+    <p:wipe dir="r"/>
+  </p:transition>
 </p:sld>
 </file>
 
@@ -10630,6 +10645,9 @@
   <p:clrMapOvr>
     <a:masterClrMapping/>
   </p:clrMapOvr>
+  <p:transition spd="med">
+    <p:fade/>
+  </p:transition>
 </p:sld>
 </file>
 
@@ -11213,6 +11231,9 @@
   <p:clrMapOvr>
     <a:masterClrMapping/>
   </p:clrMapOvr>
+  <p:transition spd="med">
+    <p:push dir="l"/>
+  </p:transition>
 </p:sld>
 </file>
 
@@ -13987,6 +14008,9 @@
   <p:clrMapOvr>
     <a:masterClrMapping/>
   </p:clrMapOvr>
+  <p:transition spd="med">
+    <p:zoom dir="out"/>
+  </p:transition>
 </p:sld>
 </file>
 
@@ -15013,6 +15037,9 @@
   <p:clrMapOvr>
     <a:masterClrMapping/>
   </p:clrMapOvr>
+  <p:transition spd="med">
+    <p:push dir="u"/>
+  </p:transition>
 </p:sld>
 </file>
 
@@ -15671,6 +15698,9 @@
   <p:clrMapOvr>
     <a:masterClrMapping/>
   </p:clrMapOvr>
+  <p:transition spd="med">
+    <p:fade/>
+  </p:transition>
 </p:sld>
 </file>
 

</xml_diff>